<commit_message>
Merge task 1 and 2 appendix slides into one
Co-Authored-By: Claude Opus 5.5 <noreply@anthropic.com>
Claude-Session: https://claude.ai/code/session_014TbtPTXZRwab3hp8YY9eJi
</commit_message>
<xml_diff>
--- a/Task_01_02.pptx
+++ b/Task_01_02.pptx
@@ -6,7 +6,6 @@
   </p:sldMasterIdLst>
   <p:sldIdLst>
     <p:sldId id="256" r:id="rId7"/>
-    <p:sldId id="257" r:id="rId8"/>
   </p:sldIdLst>
   <p:sldSz cx="12191695" cy="6858000" type="screen4x3"/>
   <p:notesSz cx="6858000" cy="9144000"/>
@@ -3121,7 +3120,7 @@
                 <a:ea typeface="맑은 고딕"/>
                 <a:cs typeface="맑은 고딕"/>
               </a:rPr>
-              <a:t>별첨. 주요 Task _ ① 트렌드 분석 및 AI 진단</a:t>
+              <a:t>별첨. 주요 Task _ ①② 트렌드·AI 진단 및 Value Chain 분석</a:t>
             </a:r>
           </a:p>
         </p:txBody>
@@ -3202,7 +3201,7 @@
                 <a:ea typeface="맑은 고딕"/>
                 <a:cs typeface="맑은 고딕"/>
               </a:rPr>
-              <a:t>AI 트렌드 및 글로벌 테마파크 선도 사례 분석과 AI 활용 수준 진단을 통해 롯데월드의 AI 도입 출발점과 목표 수준을 정의</a:t>
+              <a:t>AI 트렌드·선도사 벤치마킹과 Value Chain 분석·인터뷰를 통해 롯데월드의 AI 활용 수준과 Pain Point를 진단하고, AI 적용 핵심 업무 영역 3~4개를 선정</a:t>
             </a:r>
           </a:p>
         </p:txBody>
@@ -3615,11 +3614,11 @@
             <a:avLst/>
           </a:prstGeom>
           <a:solidFill>
-            <a:srgbClr val="EDEDED"/>
+            <a:srgbClr val="262626"/>
           </a:solidFill>
-          <a:ln w="9525">
+          <a:ln w="28575">
             <a:solidFill>
-              <a:srgbClr val="D9D9D9"/>
+              <a:srgbClr val="FFE600"/>
             </a:solidFill>
           </a:ln>
           <a:effectLst/>
@@ -3646,7 +3645,7 @@
             <a:r>
               <a:rPr sz="950" b="1" i="0" u="none">
                 <a:solidFill>
-                  <a:srgbClr val="8C8C8C"/>
+                  <a:srgbClr val="FFFFFF"/>
                 </a:solidFill>
                 <a:latin typeface="맑은 고딕"/>
                 <a:ea typeface="맑은 고딕"/>
@@ -3660,7 +3659,7 @@
             <a:r>
               <a:rPr sz="950" b="1" i="0" u="none">
                 <a:solidFill>
-                  <a:srgbClr val="8C8C8C"/>
+                  <a:srgbClr val="FFFFFF"/>
                 </a:solidFill>
                 <a:latin typeface="맑은 고딕"/>
                 <a:ea typeface="맑은 고딕"/>
@@ -3686,7 +3685,7 @@
             <a:avLst/>
           </a:prstGeom>
           <a:solidFill>
-            <a:srgbClr val="BFBFBF"/>
+            <a:srgbClr val="FFE600"/>
           </a:solidFill>
           <a:ln>
             <a:noFill/>
@@ -4365,7 +4364,7 @@
         <p:spPr>
           <a:xfrm>
             <a:off x="292608" y="3017520"/>
-            <a:ext cx="1097280" cy="201168"/>
+            <a:ext cx="1856232" cy="201168"/>
           </a:xfrm>
           <a:prstGeom prst="rect">
             <a:avLst/>
@@ -4475,7 +4474,7 @@
                   </a:tcPr>
                 </a:tc>
               </a:tr>
-              <a:tr h="914400">
+              <a:tr h="685800">
                 <a:tc>
                   <a:txBody>
                     <a:bodyPr wrap="square"/>
@@ -4495,7 +4494,7 @@
                           <a:ea typeface="맑은 고딕"/>
                           <a:cs typeface="맑은 고딕"/>
                         </a:rPr>
-                        <a:t>AI 트렌드</a:t>
+                        <a:t>AI 트렌드·</a:t>
                       </a:r>
                     </a:p>
                     <a:p>
@@ -4513,7 +4512,7 @@
                           <a:ea typeface="맑은 고딕"/>
                           <a:cs typeface="맑은 고딕"/>
                         </a:rPr>
-                        <a:t>리서치</a:t>
+                        <a:t>선도사 벤치마킹</a:t>
                       </a:r>
                     </a:p>
                   </a:txBody>
@@ -4582,7 +4581,7 @@
                           <a:ea typeface="맑은 고딕"/>
                           <a:cs typeface="맑은 고딕"/>
                         </a:rPr>
-                        <a:t>업무 재설계·가치 창출 관점의 AI 패러다임 변화 정리</a:t>
+                        <a:t>글로벌 테마파크(Disney·Universal·Chimelong 등) 영역별 AI 활용 사례 분석</a:t>
                       </a:r>
                     </a:p>
                   </a:txBody>
@@ -4593,125 +4592,7 @@
                   </a:tcPr>
                 </a:tc>
               </a:tr>
-              <a:tr h="914400">
-                <a:tc>
-                  <a:txBody>
-                    <a:bodyPr wrap="square"/>
-                    <a:lstStyle/>
-                    <a:p>
-                      <a:pPr algn="ctr">
-                        <a:spcAft>
-                          <a:spcPts val="300"/>
-                        </a:spcAft>
-                      </a:pPr>
-                      <a:r>
-                        <a:rPr sz="1200" b="1" i="0" u="none">
-                          <a:solidFill>
-                            <a:srgbClr val="262626"/>
-                          </a:solidFill>
-                          <a:latin typeface="맑은 고딕"/>
-                          <a:ea typeface="맑은 고딕"/>
-                          <a:cs typeface="맑은 고딕"/>
-                        </a:rPr>
-                        <a:t>선도사</a:t>
-                      </a:r>
-                    </a:p>
-                    <a:p>
-                      <a:pPr algn="ctr">
-                        <a:spcAft>
-                          <a:spcPts val="300"/>
-                        </a:spcAft>
-                      </a:pPr>
-                      <a:r>
-                        <a:rPr sz="1200" b="1" i="0" u="none">
-                          <a:solidFill>
-                            <a:srgbClr val="262626"/>
-                          </a:solidFill>
-                          <a:latin typeface="맑은 고딕"/>
-                          <a:ea typeface="맑은 고딕"/>
-                          <a:cs typeface="맑은 고딕"/>
-                        </a:rPr>
-                        <a:t>벤치마킹</a:t>
-                      </a:r>
-                    </a:p>
-                  </a:txBody>
-                  <a:tcPr anchor="ctr" marL="109728" marR="73152">
-                    <a:solidFill>
-                      <a:srgbClr val="F2F2F2"/>
-                    </a:solidFill>
-                  </a:tcPr>
-                </a:tc>
-                <a:tc>
-                  <a:txBody>
-                    <a:bodyPr wrap="square"/>
-                    <a:lstStyle/>
-                    <a:p>
-                      <a:pPr algn="l">
-                        <a:spcAft>
-                          <a:spcPts val="300"/>
-                        </a:spcAft>
-                      </a:pPr>
-                      <a:r>
-                        <a:rPr sz="1100" b="0" i="0" u="none">
-                          <a:solidFill>
-                            <a:srgbClr val="262626"/>
-                          </a:solidFill>
-                          <a:latin typeface="맑은 고딕"/>
-                          <a:ea typeface="맑은 고딕"/>
-                          <a:cs typeface="맑은 고딕"/>
-                        </a:rPr>
-                        <a:t>• </a:t>
-                      </a:r>
-                      <a:r>
-                        <a:rPr sz="1100" b="0" i="0" u="none">
-                          <a:solidFill>
-                            <a:srgbClr val="262626"/>
-                          </a:solidFill>
-                          <a:latin typeface="맑은 고딕"/>
-                          <a:ea typeface="맑은 고딕"/>
-                          <a:cs typeface="맑은 고딕"/>
-                        </a:rPr>
-                        <a:t>글로벌 테마파크(Disney·Universal·Chimelong 등) AI 활용 사례</a:t>
-                      </a:r>
-                    </a:p>
-                    <a:p>
-                      <a:pPr algn="l">
-                        <a:spcAft>
-                          <a:spcPts val="300"/>
-                        </a:spcAft>
-                      </a:pPr>
-                      <a:r>
-                        <a:rPr sz="1100" b="0" i="0" u="none">
-                          <a:solidFill>
-                            <a:srgbClr val="262626"/>
-                          </a:solidFill>
-                          <a:latin typeface="맑은 고딕"/>
-                          <a:ea typeface="맑은 고딕"/>
-                          <a:cs typeface="맑은 고딕"/>
-                        </a:rPr>
-                        <a:t>• </a:t>
-                      </a:r>
-                      <a:r>
-                        <a:rPr sz="1100" b="0" i="0" u="none">
-                          <a:solidFill>
-                            <a:srgbClr val="262626"/>
-                          </a:solidFill>
-                          <a:latin typeface="맑은 고딕"/>
-                          <a:ea typeface="맑은 고딕"/>
-                          <a:cs typeface="맑은 고딕"/>
-                        </a:rPr>
-                        <a:t>영역별(운영 효율·고객 경험·콘텐츠) 적용 방식 및 성과 분석</a:t>
-                      </a:r>
-                    </a:p>
-                  </a:txBody>
-                  <a:tcPr anchor="ctr" marL="109728" marR="73152">
-                    <a:solidFill>
-                      <a:srgbClr val="FFFFFF"/>
-                    </a:solidFill>
-                  </a:tcPr>
-                </a:tc>
-              </a:tr>
-              <a:tr h="914400">
+              <a:tr h="685800">
                 <a:tc>
                   <a:txBody>
                     <a:bodyPr wrap="square"/>
@@ -4829,1847 +4710,7 @@
                   </a:tcPr>
                 </a:tc>
               </a:tr>
-            </a:tbl>
-          </a:graphicData>
-        </a:graphic>
-      </p:graphicFrame>
-      <p:sp>
-        <p:nvSpPr>
-          <p:cNvPr id="27" name="TextBox 26"/>
-          <p:cNvSpPr txBox="1"/>
-          <p:nvPr/>
-        </p:nvSpPr>
-        <p:spPr>
-          <a:xfrm>
-            <a:off x="6263640" y="1417320"/>
-            <a:ext cx="5577840" cy="329184"/>
-          </a:xfrm>
-          <a:prstGeom prst="rect">
-            <a:avLst/>
-          </a:prstGeom>
-          <a:noFill/>
-        </p:spPr>
-        <p:txBody>
-          <a:bodyPr wrap="square" lIns="18288" rIns="18288" tIns="18288" bIns="18288" anchor="ctr">
-            <a:spAutoFit/>
-          </a:bodyPr>
-          <a:lstStyle/>
-          <a:p>
-            <a:pPr algn="ctr"/>
-            <a:r>
-              <a:rPr sz="1600" b="1" i="0" u="none">
-                <a:solidFill>
-                  <a:srgbClr val="262626"/>
-                </a:solidFill>
-                <a:latin typeface="맑은 고딕"/>
-                <a:ea typeface="맑은 고딕"/>
-                <a:cs typeface="맑은 고딕"/>
-              </a:rPr>
-              <a:t>주요 산출물</a:t>
-            </a:r>
-          </a:p>
-        </p:txBody>
-      </p:sp>
-      <p:cxnSp>
-        <p:nvCxnSpPr>
-          <p:cNvPr id="28" name="Connector 27"/>
-          <p:cNvCxnSpPr/>
-          <p:nvPr/>
-        </p:nvCxnSpPr>
-        <p:spPr>
-          <a:xfrm>
-            <a:off x="6263640" y="1755648"/>
-            <a:ext cx="5577840" cy="0"/>
-          </a:xfrm>
-          <a:prstGeom prst="line">
-            <a:avLst/>
-          </a:prstGeom>
-          <a:ln w="25400">
-            <a:solidFill>
-              <a:srgbClr val="262626"/>
-            </a:solidFill>
-          </a:ln>
-        </p:spPr>
-        <p:style>
-          <a:lnRef idx="2">
-            <a:schemeClr val="accent1"/>
-          </a:lnRef>
-          <a:fillRef idx="0">
-            <a:schemeClr val="accent1"/>
-          </a:fillRef>
-          <a:effectRef idx="1">
-            <a:schemeClr val="accent1"/>
-          </a:effectRef>
-          <a:fontRef idx="minor">
-            <a:schemeClr val="tx1"/>
-          </a:fontRef>
-        </p:style>
-      </p:cxnSp>
-      <p:sp>
-        <p:nvSpPr>
-          <p:cNvPr id="29" name="Rectangle 28"/>
-          <p:cNvSpPr/>
-          <p:nvPr/>
-        </p:nvSpPr>
-        <p:spPr>
-          <a:xfrm>
-            <a:off x="6263640" y="1847088"/>
-            <a:ext cx="5577840" cy="2286000"/>
-          </a:xfrm>
-          <a:prstGeom prst="rect">
-            <a:avLst/>
-          </a:prstGeom>
-          <a:solidFill>
-            <a:srgbClr val="FFFFFF"/>
-          </a:solidFill>
-          <a:ln w="12700">
-            <a:solidFill>
-              <a:srgbClr val="D9D9D9"/>
-            </a:solidFill>
-          </a:ln>
-          <a:effectLst/>
-        </p:spPr>
-        <p:style>
-          <a:lnRef idx="1">
-            <a:schemeClr val="accent1"/>
-          </a:lnRef>
-          <a:fillRef idx="3">
-            <a:schemeClr val="accent1"/>
-          </a:fillRef>
-          <a:effectRef idx="2">
-            <a:schemeClr val="accent1"/>
-          </a:effectRef>
-          <a:fontRef idx="minor">
-            <a:schemeClr val="lt1"/>
-          </a:fontRef>
-        </p:style>
-        <p:txBody>
-          <a:bodyPr rtlCol="0" anchor="ctr"/>
-          <a:lstStyle/>
-          <a:p>
-            <a:pPr algn="ctr"/>
-          </a:p>
-        </p:txBody>
-      </p:sp>
-      <p:pic>
-        <p:nvPicPr>
-          <p:cNvPr id="30" name="Picture 29" descr="mk_t1a.png"/>
-          <p:cNvPicPr>
-            <a:picLocks noChangeAspect="1"/>
-          </p:cNvPicPr>
-          <p:nvPr/>
-        </p:nvPicPr>
-        <p:blipFill>
-          <a:blip r:embed="rId2"/>
-          <a:stretch>
-            <a:fillRect/>
-          </a:stretch>
-        </p:blipFill>
-        <p:spPr>
-          <a:xfrm>
-            <a:off x="6949440" y="1938528"/>
-            <a:ext cx="4206240" cy="1828800"/>
-          </a:xfrm>
-          <a:prstGeom prst="rect">
-            <a:avLst/>
-          </a:prstGeom>
-        </p:spPr>
-      </p:pic>
-      <p:sp>
-        <p:nvSpPr>
-          <p:cNvPr id="31" name="TextBox 30"/>
-          <p:cNvSpPr txBox="1"/>
-          <p:nvPr/>
-        </p:nvSpPr>
-        <p:spPr>
-          <a:xfrm>
-            <a:off x="10241280" y="1901952"/>
-            <a:ext cx="1508760" cy="329184"/>
-          </a:xfrm>
-          <a:prstGeom prst="rect">
-            <a:avLst/>
-          </a:prstGeom>
-          <a:noFill/>
-        </p:spPr>
-        <p:txBody>
-          <a:bodyPr wrap="square" lIns="18288" rIns="18288" tIns="18288" bIns="18288" anchor="ctr">
-            <a:spAutoFit/>
-          </a:bodyPr>
-          <a:lstStyle/>
-          <a:p>
-            <a:pPr algn="r"/>
-            <a:r>
-              <a:rPr sz="1800" b="1" i="1" u="sng">
-                <a:solidFill>
-                  <a:srgbClr val="C62828"/>
-                </a:solidFill>
-                <a:latin typeface="맑은 고딕"/>
-                <a:ea typeface="맑은 고딕"/>
-                <a:cs typeface="맑은 고딕"/>
-              </a:rPr>
-              <a:t>illustrative</a:t>
-            </a:r>
-          </a:p>
-        </p:txBody>
-      </p:sp>
-      <p:sp>
-        <p:nvSpPr>
-          <p:cNvPr id="32" name="Rectangle 31"/>
-          <p:cNvSpPr/>
-          <p:nvPr/>
-        </p:nvSpPr>
-        <p:spPr>
-          <a:xfrm>
-            <a:off x="6263640" y="3767328"/>
-            <a:ext cx="5577840" cy="365760"/>
-          </a:xfrm>
-          <a:prstGeom prst="rect">
-            <a:avLst/>
-          </a:prstGeom>
-          <a:solidFill>
-            <a:srgbClr val="F2F2F2"/>
-          </a:solidFill>
-          <a:ln>
-            <a:noFill/>
-          </a:ln>
-          <a:effectLst/>
-        </p:spPr>
-        <p:style>
-          <a:lnRef idx="1">
-            <a:schemeClr val="accent1"/>
-          </a:lnRef>
-          <a:fillRef idx="3">
-            <a:schemeClr val="accent1"/>
-          </a:fillRef>
-          <a:effectRef idx="2">
-            <a:schemeClr val="accent1"/>
-          </a:effectRef>
-          <a:fontRef idx="minor">
-            <a:schemeClr val="lt1"/>
-          </a:fontRef>
-        </p:style>
-        <p:txBody>
-          <a:bodyPr rtlCol="0" anchor="ctr" wrap="square" lIns="18288" rIns="18288" tIns="18288" bIns="18288"/>
-          <a:lstStyle/>
-          <a:p>
-            <a:pPr algn="ctr"/>
-            <a:r>
-              <a:rPr sz="1350" b="1" i="0" u="none">
-                <a:solidFill>
-                  <a:srgbClr val="262626"/>
-                </a:solidFill>
-                <a:latin typeface="맑은 고딕"/>
-                <a:ea typeface="맑은 고딕"/>
-                <a:cs typeface="맑은 고딕"/>
-              </a:rPr>
-              <a:t>AI 트렌드 및 선도사 벤치마킹 분석서</a:t>
-            </a:r>
-          </a:p>
-        </p:txBody>
-      </p:sp>
-      <p:sp>
-        <p:nvSpPr>
-          <p:cNvPr id="33" name="Rectangle 32"/>
-          <p:cNvSpPr/>
-          <p:nvPr/>
-        </p:nvSpPr>
-        <p:spPr>
-          <a:xfrm>
-            <a:off x="6263640" y="4224528"/>
-            <a:ext cx="5577840" cy="2286000"/>
-          </a:xfrm>
-          <a:prstGeom prst="rect">
-            <a:avLst/>
-          </a:prstGeom>
-          <a:solidFill>
-            <a:srgbClr val="FFFFFF"/>
-          </a:solidFill>
-          <a:ln w="12700">
-            <a:solidFill>
-              <a:srgbClr val="D9D9D9"/>
-            </a:solidFill>
-          </a:ln>
-          <a:effectLst/>
-        </p:spPr>
-        <p:style>
-          <a:lnRef idx="1">
-            <a:schemeClr val="accent1"/>
-          </a:lnRef>
-          <a:fillRef idx="3">
-            <a:schemeClr val="accent1"/>
-          </a:fillRef>
-          <a:effectRef idx="2">
-            <a:schemeClr val="accent1"/>
-          </a:effectRef>
-          <a:fontRef idx="minor">
-            <a:schemeClr val="lt1"/>
-          </a:fontRef>
-        </p:style>
-        <p:txBody>
-          <a:bodyPr rtlCol="0" anchor="ctr"/>
-          <a:lstStyle/>
-          <a:p>
-            <a:pPr algn="ctr"/>
-          </a:p>
-        </p:txBody>
-      </p:sp>
-      <p:pic>
-        <p:nvPicPr>
-          <p:cNvPr id="34" name="Picture 33" descr="mk_t1b.png"/>
-          <p:cNvPicPr>
-            <a:picLocks noChangeAspect="1"/>
-          </p:cNvPicPr>
-          <p:nvPr/>
-        </p:nvPicPr>
-        <p:blipFill>
-          <a:blip r:embed="rId3"/>
-          <a:stretch>
-            <a:fillRect/>
-          </a:stretch>
-        </p:blipFill>
-        <p:spPr>
-          <a:xfrm>
-            <a:off x="6949440" y="4315968"/>
-            <a:ext cx="4206240" cy="1828800"/>
-          </a:xfrm>
-          <a:prstGeom prst="rect">
-            <a:avLst/>
-          </a:prstGeom>
-        </p:spPr>
-      </p:pic>
-      <p:sp>
-        <p:nvSpPr>
-          <p:cNvPr id="35" name="TextBox 34"/>
-          <p:cNvSpPr txBox="1"/>
-          <p:nvPr/>
-        </p:nvSpPr>
-        <p:spPr>
-          <a:xfrm>
-            <a:off x="10241280" y="4279392"/>
-            <a:ext cx="1508760" cy="329184"/>
-          </a:xfrm>
-          <a:prstGeom prst="rect">
-            <a:avLst/>
-          </a:prstGeom>
-          <a:noFill/>
-        </p:spPr>
-        <p:txBody>
-          <a:bodyPr wrap="square" lIns="18288" rIns="18288" tIns="18288" bIns="18288" anchor="ctr">
-            <a:spAutoFit/>
-          </a:bodyPr>
-          <a:lstStyle/>
-          <a:p>
-            <a:pPr algn="r"/>
-            <a:r>
-              <a:rPr sz="1800" b="1" i="1" u="sng">
-                <a:solidFill>
-                  <a:srgbClr val="C62828"/>
-                </a:solidFill>
-                <a:latin typeface="맑은 고딕"/>
-                <a:ea typeface="맑은 고딕"/>
-                <a:cs typeface="맑은 고딕"/>
-              </a:rPr>
-              <a:t>illustrative</a:t>
-            </a:r>
-          </a:p>
-        </p:txBody>
-      </p:sp>
-      <p:sp>
-        <p:nvSpPr>
-          <p:cNvPr id="36" name="Rectangle 35"/>
-          <p:cNvSpPr/>
-          <p:nvPr/>
-        </p:nvSpPr>
-        <p:spPr>
-          <a:xfrm>
-            <a:off x="6263640" y="6144768"/>
-            <a:ext cx="5577840" cy="365760"/>
-          </a:xfrm>
-          <a:prstGeom prst="rect">
-            <a:avLst/>
-          </a:prstGeom>
-          <a:solidFill>
-            <a:srgbClr val="F2F2F2"/>
-          </a:solidFill>
-          <a:ln>
-            <a:noFill/>
-          </a:ln>
-          <a:effectLst/>
-        </p:spPr>
-        <p:style>
-          <a:lnRef idx="1">
-            <a:schemeClr val="accent1"/>
-          </a:lnRef>
-          <a:fillRef idx="3">
-            <a:schemeClr val="accent1"/>
-          </a:fillRef>
-          <a:effectRef idx="2">
-            <a:schemeClr val="accent1"/>
-          </a:effectRef>
-          <a:fontRef idx="minor">
-            <a:schemeClr val="lt1"/>
-          </a:fontRef>
-        </p:style>
-        <p:txBody>
-          <a:bodyPr rtlCol="0" anchor="ctr" wrap="square" lIns="18288" rIns="18288" tIns="18288" bIns="18288"/>
-          <a:lstStyle/>
-          <a:p>
-            <a:pPr algn="ctr"/>
-            <a:r>
-              <a:rPr sz="1350" b="1" i="0" u="none">
-                <a:solidFill>
-                  <a:srgbClr val="262626"/>
-                </a:solidFill>
-                <a:latin typeface="맑은 고딕"/>
-                <a:ea typeface="맑은 고딕"/>
-                <a:cs typeface="맑은 고딕"/>
-              </a:rPr>
-              <a:t>AI 활용 수준 진단서</a:t>
-            </a:r>
-          </a:p>
-        </p:txBody>
-      </p:sp>
-      <p:cxnSp>
-        <p:nvCxnSpPr>
-          <p:cNvPr id="37" name="Connector 36"/>
-          <p:cNvCxnSpPr/>
-          <p:nvPr/>
-        </p:nvCxnSpPr>
-        <p:spPr>
-          <a:xfrm>
-            <a:off x="6126480" y="1417320"/>
-            <a:ext cx="0" cy="5120640"/>
-          </a:xfrm>
-          <a:prstGeom prst="line">
-            <a:avLst/>
-          </a:prstGeom>
-          <a:ln w="9525">
-            <a:solidFill>
-              <a:srgbClr val="D9D9D9"/>
-            </a:solidFill>
-            <a:prstDash val="dash"/>
-          </a:ln>
-        </p:spPr>
-        <p:style>
-          <a:lnRef idx="2">
-            <a:schemeClr val="accent1"/>
-          </a:lnRef>
-          <a:fillRef idx="0">
-            <a:schemeClr val="accent1"/>
-          </a:fillRef>
-          <a:effectRef idx="1">
-            <a:schemeClr val="accent1"/>
-          </a:effectRef>
-          <a:fontRef idx="minor">
-            <a:schemeClr val="tx1"/>
-          </a:fontRef>
-        </p:style>
-      </p:cxnSp>
-    </p:spTree>
-  </p:cSld>
-  <p:clrMapOvr>
-    <a:masterClrMapping/>
-  </p:clrMapOvr>
-</p:sld>
-</file>
-
-<file path=ppt/slides/slide2.xml><?xml version="1.0" encoding="utf-8"?>
-<p:sld xmlns:a="http://schemas.openxmlformats.org/drawingml/2006/main" xmlns:p="http://schemas.openxmlformats.org/presentationml/2006/main" xmlns:r="http://schemas.openxmlformats.org/officeDocument/2006/relationships">
-  <p:cSld>
-    <p:spTree>
-      <p:nvGrpSpPr>
-        <p:cNvPr id="1" name=""/>
-        <p:cNvGrpSpPr/>
-        <p:nvPr/>
-      </p:nvGrpSpPr>
-      <p:grpSpPr/>
-      <p:sp>
-        <p:nvSpPr>
-          <p:cNvPr id="2" name="TextBox 1"/>
-          <p:cNvSpPr txBox="1"/>
-          <p:nvPr/>
-        </p:nvSpPr>
-        <p:spPr>
-          <a:xfrm>
-            <a:off x="365760" y="182880"/>
-            <a:ext cx="11430000" cy="548640"/>
-          </a:xfrm>
-          <a:prstGeom prst="rect">
-            <a:avLst/>
-          </a:prstGeom>
-          <a:noFill/>
-        </p:spPr>
-        <p:txBody>
-          <a:bodyPr wrap="square" lIns="18288" rIns="18288" tIns="18288" bIns="18288" anchor="ctr">
-            <a:spAutoFit/>
-          </a:bodyPr>
-          <a:lstStyle/>
-          <a:p>
-            <a:pPr algn="l"/>
-            <a:r>
-              <a:rPr sz="2600" b="1" i="0" u="none">
-                <a:solidFill>
-                  <a:srgbClr val="262626"/>
-                </a:solidFill>
-                <a:latin typeface="맑은 고딕"/>
-                <a:ea typeface="맑은 고딕"/>
-                <a:cs typeface="맑은 고딕"/>
-              </a:rPr>
-              <a:t>별첨. 주요 Task _ ② Value Chain 분석 / 인터뷰</a:t>
-            </a:r>
-          </a:p>
-        </p:txBody>
-      </p:sp>
-      <p:sp>
-        <p:nvSpPr>
-          <p:cNvPr id="3" name="Rectangle 2"/>
-          <p:cNvSpPr/>
-          <p:nvPr/>
-        </p:nvSpPr>
-        <p:spPr>
-          <a:xfrm>
-            <a:off x="365760" y="841248"/>
-            <a:ext cx="64008" cy="411480"/>
-          </a:xfrm>
-          <a:prstGeom prst="rect">
-            <a:avLst/>
-          </a:prstGeom>
-          <a:solidFill>
-            <a:srgbClr val="404040"/>
-          </a:solidFill>
-          <a:ln>
-            <a:noFill/>
-          </a:ln>
-          <a:effectLst/>
-        </p:spPr>
-        <p:style>
-          <a:lnRef idx="1">
-            <a:schemeClr val="accent1"/>
-          </a:lnRef>
-          <a:fillRef idx="3">
-            <a:schemeClr val="accent1"/>
-          </a:fillRef>
-          <a:effectRef idx="2">
-            <a:schemeClr val="accent1"/>
-          </a:effectRef>
-          <a:fontRef idx="minor">
-            <a:schemeClr val="lt1"/>
-          </a:fontRef>
-        </p:style>
-        <p:txBody>
-          <a:bodyPr rtlCol="0" anchor="ctr"/>
-          <a:lstStyle/>
-          <a:p>
-            <a:pPr algn="ctr"/>
-          </a:p>
-        </p:txBody>
-      </p:sp>
-      <p:sp>
-        <p:nvSpPr>
-          <p:cNvPr id="4" name="TextBox 3"/>
-          <p:cNvSpPr txBox="1"/>
-          <p:nvPr/>
-        </p:nvSpPr>
-        <p:spPr>
-          <a:xfrm>
-            <a:off x="548640" y="777240"/>
-            <a:ext cx="11247120" cy="548640"/>
-          </a:xfrm>
-          <a:prstGeom prst="rect">
-            <a:avLst/>
-          </a:prstGeom>
-          <a:noFill/>
-        </p:spPr>
-        <p:txBody>
-          <a:bodyPr wrap="square" lIns="18288" rIns="18288" tIns="18288" bIns="18288" anchor="ctr">
-            <a:spAutoFit/>
-          </a:bodyPr>
-          <a:lstStyle/>
-          <a:p>
-            <a:pPr algn="l"/>
-            <a:r>
-              <a:rPr sz="1550" b="1" i="0" u="none">
-                <a:solidFill>
-                  <a:srgbClr val="404040"/>
-                </a:solidFill>
-                <a:latin typeface="맑은 고딕"/>
-                <a:ea typeface="맑은 고딕"/>
-                <a:cs typeface="맑은 고딕"/>
-              </a:rPr>
-              <a:t>롯데월드 Value Chain 정의와 경영진·실무자 인터뷰를 통해 Pain Point를 파악하고, AI 적용을 우선 검토할 핵심 업무 영역 3~4개를 선정</a:t>
-            </a:r>
-          </a:p>
-        </p:txBody>
-      </p:sp>
-      <p:cxnSp>
-        <p:nvCxnSpPr>
-          <p:cNvPr id="5" name="Connector 4"/>
-          <p:cNvCxnSpPr/>
-          <p:nvPr/>
-        </p:nvCxnSpPr>
-        <p:spPr>
-          <a:xfrm>
-            <a:off x="365760" y="1344168"/>
-            <a:ext cx="11475720" cy="0"/>
-          </a:xfrm>
-          <a:prstGeom prst="line">
-            <a:avLst/>
-          </a:prstGeom>
-          <a:ln w="9525">
-            <a:solidFill>
-              <a:srgbClr val="D9D9D9"/>
-            </a:solidFill>
-          </a:ln>
-        </p:spPr>
-        <p:style>
-          <a:lnRef idx="2">
-            <a:schemeClr val="accent1"/>
-          </a:lnRef>
-          <a:fillRef idx="0">
-            <a:schemeClr val="accent1"/>
-          </a:fillRef>
-          <a:effectRef idx="1">
-            <a:schemeClr val="accent1"/>
-          </a:effectRef>
-          <a:fontRef idx="minor">
-            <a:schemeClr val="tx1"/>
-          </a:fontRef>
-        </p:style>
-      </p:cxnSp>
-      <p:sp>
-        <p:nvSpPr>
-          <p:cNvPr id="6" name="TextBox 5"/>
-          <p:cNvSpPr txBox="1"/>
-          <p:nvPr/>
-        </p:nvSpPr>
-        <p:spPr>
-          <a:xfrm>
-            <a:off x="365760" y="1417320"/>
-            <a:ext cx="5623560" cy="329184"/>
-          </a:xfrm>
-          <a:prstGeom prst="rect">
-            <a:avLst/>
-          </a:prstGeom>
-          <a:noFill/>
-        </p:spPr>
-        <p:txBody>
-          <a:bodyPr wrap="square" lIns="18288" rIns="18288" tIns="18288" bIns="18288" anchor="ctr">
-            <a:spAutoFit/>
-          </a:bodyPr>
-          <a:lstStyle/>
-          <a:p>
-            <a:pPr algn="ctr"/>
-            <a:r>
-              <a:rPr sz="1600" b="1" i="0" u="none">
-                <a:solidFill>
-                  <a:srgbClr val="262626"/>
-                </a:solidFill>
-                <a:latin typeface="맑은 고딕"/>
-                <a:ea typeface="맑은 고딕"/>
-                <a:cs typeface="맑은 고딕"/>
-              </a:rPr>
-              <a:t>주요 수행내역</a:t>
-            </a:r>
-          </a:p>
-        </p:txBody>
-      </p:sp>
-      <p:cxnSp>
-        <p:nvCxnSpPr>
-          <p:cNvPr id="7" name="Connector 6"/>
-          <p:cNvCxnSpPr/>
-          <p:nvPr/>
-        </p:nvCxnSpPr>
-        <p:spPr>
-          <a:xfrm>
-            <a:off x="365760" y="1755648"/>
-            <a:ext cx="5623560" cy="0"/>
-          </a:xfrm>
-          <a:prstGeom prst="line">
-            <a:avLst/>
-          </a:prstGeom>
-          <a:ln w="25400">
-            <a:solidFill>
-              <a:srgbClr val="262626"/>
-            </a:solidFill>
-          </a:ln>
-        </p:spPr>
-        <p:style>
-          <a:lnRef idx="2">
-            <a:schemeClr val="accent1"/>
-          </a:lnRef>
-          <a:fillRef idx="0">
-            <a:schemeClr val="accent1"/>
-          </a:fillRef>
-          <a:effectRef idx="1">
-            <a:schemeClr val="accent1"/>
-          </a:effectRef>
-          <a:fontRef idx="minor">
-            <a:schemeClr val="tx1"/>
-          </a:fontRef>
-        </p:style>
-      </p:cxnSp>
-      <p:sp>
-        <p:nvSpPr>
-          <p:cNvPr id="8" name="Rectangle 7"/>
-          <p:cNvSpPr/>
-          <p:nvPr/>
-        </p:nvSpPr>
-        <p:spPr>
-          <a:xfrm>
-            <a:off x="365760" y="1755648"/>
-            <a:ext cx="5623560" cy="1481328"/>
-          </a:xfrm>
-          <a:prstGeom prst="rect">
-            <a:avLst/>
-          </a:prstGeom>
-          <a:solidFill>
-            <a:srgbClr val="FFFFFF"/>
-          </a:solidFill>
-          <a:ln w="12700">
-            <a:solidFill>
-              <a:srgbClr val="D9D9D9"/>
-            </a:solidFill>
-          </a:ln>
-          <a:effectLst/>
-        </p:spPr>
-        <p:style>
-          <a:lnRef idx="1">
-            <a:schemeClr val="accent1"/>
-          </a:lnRef>
-          <a:fillRef idx="3">
-            <a:schemeClr val="accent1"/>
-          </a:fillRef>
-          <a:effectRef idx="2">
-            <a:schemeClr val="accent1"/>
-          </a:effectRef>
-          <a:fontRef idx="minor">
-            <a:schemeClr val="lt1"/>
-          </a:fontRef>
-        </p:style>
-        <p:txBody>
-          <a:bodyPr rtlCol="0" anchor="ctr"/>
-          <a:lstStyle/>
-          <a:p>
-            <a:pPr algn="ctr"/>
-          </a:p>
-        </p:txBody>
-      </p:sp>
-      <p:sp>
-        <p:nvSpPr>
-          <p:cNvPr id="9" name="Pentagon 8"/>
-          <p:cNvSpPr/>
-          <p:nvPr/>
-        </p:nvSpPr>
-        <p:spPr>
-          <a:xfrm>
-            <a:off x="457200" y="1847088"/>
-            <a:ext cx="2423160" cy="292608"/>
-          </a:xfrm>
-          <a:prstGeom prst="homePlate">
-            <a:avLst>
-              <a:gd name="adj" fmla="val 30000"/>
-            </a:avLst>
-          </a:prstGeom>
-          <a:solidFill>
-            <a:srgbClr val="404040"/>
-          </a:solidFill>
-          <a:ln>
-            <a:noFill/>
-          </a:ln>
-          <a:effectLst/>
-        </p:spPr>
-        <p:style>
-          <a:lnRef idx="1">
-            <a:schemeClr val="accent1"/>
-          </a:lnRef>
-          <a:fillRef idx="3">
-            <a:schemeClr val="accent1"/>
-          </a:fillRef>
-          <a:effectRef idx="2">
-            <a:schemeClr val="accent1"/>
-          </a:effectRef>
-          <a:fontRef idx="minor">
-            <a:schemeClr val="lt1"/>
-          </a:fontRef>
-        </p:style>
-        <p:txBody>
-          <a:bodyPr rtlCol="0" anchor="ctr" wrap="square" lIns="18288" rIns="18288" tIns="18288" bIns="18288"/>
-          <a:lstStyle/>
-          <a:p>
-            <a:pPr algn="ctr"/>
-            <a:r>
-              <a:rPr sz="1050" b="1" i="0" u="none">
-                <a:solidFill>
-                  <a:srgbClr val="FFFFFF"/>
-                </a:solidFill>
-                <a:latin typeface="맑은 고딕"/>
-                <a:ea typeface="맑은 고딕"/>
-                <a:cs typeface="맑은 고딕"/>
-              </a:rPr>
-              <a:t>AI 과제 발굴 (W1~W2)</a:t>
-            </a:r>
-          </a:p>
-        </p:txBody>
-      </p:sp>
-      <p:sp>
-        <p:nvSpPr>
-          <p:cNvPr id="10" name="Chevron 9"/>
-          <p:cNvSpPr/>
-          <p:nvPr/>
-        </p:nvSpPr>
-        <p:spPr>
-          <a:xfrm>
-            <a:off x="2852928" y="1847088"/>
-            <a:ext cx="3044952" cy="292608"/>
-          </a:xfrm>
-          <a:prstGeom prst="chevron">
-            <a:avLst>
-              <a:gd name="adj" fmla="val 30000"/>
-            </a:avLst>
-          </a:prstGeom>
-          <a:solidFill>
-            <a:srgbClr val="BFBFBF"/>
-          </a:solidFill>
-          <a:ln>
-            <a:noFill/>
-          </a:ln>
-          <a:effectLst/>
-        </p:spPr>
-        <p:style>
-          <a:lnRef idx="1">
-            <a:schemeClr val="accent1"/>
-          </a:lnRef>
-          <a:fillRef idx="3">
-            <a:schemeClr val="accent1"/>
-          </a:fillRef>
-          <a:effectRef idx="2">
-            <a:schemeClr val="accent1"/>
-          </a:effectRef>
-          <a:fontRef idx="minor">
-            <a:schemeClr val="lt1"/>
-          </a:fontRef>
-        </p:style>
-        <p:txBody>
-          <a:bodyPr rtlCol="0" anchor="ctr" wrap="square" lIns="18288" rIns="18288" tIns="18288" bIns="18288"/>
-          <a:lstStyle/>
-          <a:p>
-            <a:pPr algn="ctr"/>
-            <a:r>
-              <a:rPr sz="1050" b="1" i="0" u="none">
-                <a:solidFill>
-                  <a:srgbClr val="FFFFFF"/>
-                </a:solidFill>
-                <a:latin typeface="맑은 고딕"/>
-                <a:ea typeface="맑은 고딕"/>
-                <a:cs typeface="맑은 고딕"/>
-              </a:rPr>
-              <a:t>AI 과제 구체화·프로토타입 (W3~W4)</a:t>
-            </a:r>
-          </a:p>
-        </p:txBody>
-      </p:sp>
-      <p:sp>
-        <p:nvSpPr>
-          <p:cNvPr id="11" name="Rectangle 10"/>
-          <p:cNvSpPr/>
-          <p:nvPr/>
-        </p:nvSpPr>
-        <p:spPr>
-          <a:xfrm>
-            <a:off x="475488" y="2286000"/>
-            <a:ext cx="731520" cy="713232"/>
-          </a:xfrm>
-          <a:prstGeom prst="rect">
-            <a:avLst/>
-          </a:prstGeom>
-          <a:solidFill>
-            <a:srgbClr val="EDEDED"/>
-          </a:solidFill>
-          <a:ln w="9525">
-            <a:solidFill>
-              <a:srgbClr val="D9D9D9"/>
-            </a:solidFill>
-          </a:ln>
-          <a:effectLst/>
-        </p:spPr>
-        <p:style>
-          <a:lnRef idx="1">
-            <a:schemeClr val="accent1"/>
-          </a:lnRef>
-          <a:fillRef idx="3">
-            <a:schemeClr val="accent1"/>
-          </a:fillRef>
-          <a:effectRef idx="2">
-            <a:schemeClr val="accent1"/>
-          </a:effectRef>
-          <a:fontRef idx="minor">
-            <a:schemeClr val="lt1"/>
-          </a:fontRef>
-        </p:style>
-        <p:txBody>
-          <a:bodyPr rtlCol="0" anchor="ctr" wrap="square" lIns="18288" rIns="18288" tIns="18288" bIns="18288"/>
-          <a:lstStyle/>
-          <a:p>
-            <a:pPr algn="ctr"/>
-            <a:r>
-              <a:rPr sz="950" b="1" i="0" u="none">
-                <a:solidFill>
-                  <a:srgbClr val="8C8C8C"/>
-                </a:solidFill>
-                <a:latin typeface="맑은 고딕"/>
-                <a:ea typeface="맑은 고딕"/>
-                <a:cs typeface="맑은 고딕"/>
-              </a:rPr>
-              <a:t>트렌드·</a:t>
-            </a:r>
-          </a:p>
-          <a:p>
-            <a:pPr algn="ctr"/>
-            <a:r>
-              <a:rPr sz="950" b="1" i="0" u="none">
-                <a:solidFill>
-                  <a:srgbClr val="8C8C8C"/>
-                </a:solidFill>
-                <a:latin typeface="맑은 고딕"/>
-                <a:ea typeface="맑은 고딕"/>
-                <a:cs typeface="맑은 고딕"/>
-              </a:rPr>
-              <a:t>AI 진단</a:t>
-            </a:r>
-          </a:p>
-        </p:txBody>
-      </p:sp>
-      <p:sp>
-        <p:nvSpPr>
-          <p:cNvPr id="12" name="Oval 11"/>
-          <p:cNvSpPr/>
-          <p:nvPr/>
-        </p:nvSpPr>
-        <p:spPr>
-          <a:xfrm>
-            <a:off x="740664" y="2185416"/>
-            <a:ext cx="201168" cy="201168"/>
-          </a:xfrm>
-          <a:prstGeom prst="ellipse">
-            <a:avLst/>
-          </a:prstGeom>
-          <a:solidFill>
-            <a:srgbClr val="BFBFBF"/>
-          </a:solidFill>
-          <a:ln>
-            <a:noFill/>
-          </a:ln>
-          <a:effectLst/>
-        </p:spPr>
-        <p:style>
-          <a:lnRef idx="1">
-            <a:schemeClr val="accent1"/>
-          </a:lnRef>
-          <a:fillRef idx="3">
-            <a:schemeClr val="accent1"/>
-          </a:fillRef>
-          <a:effectRef idx="2">
-            <a:schemeClr val="accent1"/>
-          </a:effectRef>
-          <a:fontRef idx="minor">
-            <a:schemeClr val="lt1"/>
-          </a:fontRef>
-        </p:style>
-        <p:txBody>
-          <a:bodyPr rtlCol="0" anchor="ctr" wrap="square" lIns="18288" rIns="18288" tIns="18288" bIns="18288"/>
-          <a:lstStyle/>
-          <a:p>
-            <a:pPr algn="ctr"/>
-            <a:r>
-              <a:rPr sz="850" b="1" i="0" u="none">
-                <a:solidFill>
-                  <a:srgbClr val="262626"/>
-                </a:solidFill>
-                <a:latin typeface="맑은 고딕"/>
-                <a:ea typeface="맑은 고딕"/>
-                <a:cs typeface="맑은 고딕"/>
-              </a:rPr>
-              <a:t>1</a:t>
-            </a:r>
-          </a:p>
-        </p:txBody>
-      </p:sp>
-      <p:sp>
-        <p:nvSpPr>
-          <p:cNvPr id="13" name="Rectangle 12"/>
-          <p:cNvSpPr/>
-          <p:nvPr/>
-        </p:nvSpPr>
-        <p:spPr>
-          <a:xfrm>
-            <a:off x="1243584" y="2286000"/>
-            <a:ext cx="731520" cy="713232"/>
-          </a:xfrm>
-          <a:prstGeom prst="rect">
-            <a:avLst/>
-          </a:prstGeom>
-          <a:solidFill>
-            <a:srgbClr val="262626"/>
-          </a:solidFill>
-          <a:ln w="28575">
-            <a:solidFill>
-              <a:srgbClr val="FFE600"/>
-            </a:solidFill>
-          </a:ln>
-          <a:effectLst/>
-        </p:spPr>
-        <p:style>
-          <a:lnRef idx="1">
-            <a:schemeClr val="accent1"/>
-          </a:lnRef>
-          <a:fillRef idx="3">
-            <a:schemeClr val="accent1"/>
-          </a:fillRef>
-          <a:effectRef idx="2">
-            <a:schemeClr val="accent1"/>
-          </a:effectRef>
-          <a:fontRef idx="minor">
-            <a:schemeClr val="lt1"/>
-          </a:fontRef>
-        </p:style>
-        <p:txBody>
-          <a:bodyPr rtlCol="0" anchor="ctr" wrap="square" lIns="18288" rIns="18288" tIns="18288" bIns="18288"/>
-          <a:lstStyle/>
-          <a:p>
-            <a:pPr algn="ctr"/>
-            <a:r>
-              <a:rPr sz="950" b="1" i="0" u="none">
-                <a:solidFill>
-                  <a:srgbClr val="FFFFFF"/>
-                </a:solidFill>
-                <a:latin typeface="맑은 고딕"/>
-                <a:ea typeface="맑은 고딕"/>
-                <a:cs typeface="맑은 고딕"/>
-              </a:rPr>
-              <a:t>VC 분석·</a:t>
-            </a:r>
-          </a:p>
-          <a:p>
-            <a:pPr algn="ctr"/>
-            <a:r>
-              <a:rPr sz="950" b="1" i="0" u="none">
-                <a:solidFill>
-                  <a:srgbClr val="FFFFFF"/>
-                </a:solidFill>
-                <a:latin typeface="맑은 고딕"/>
-                <a:ea typeface="맑은 고딕"/>
-                <a:cs typeface="맑은 고딕"/>
-              </a:rPr>
-              <a:t>인터뷰</a:t>
-            </a:r>
-          </a:p>
-        </p:txBody>
-      </p:sp>
-      <p:sp>
-        <p:nvSpPr>
-          <p:cNvPr id="14" name="Oval 13"/>
-          <p:cNvSpPr/>
-          <p:nvPr/>
-        </p:nvSpPr>
-        <p:spPr>
-          <a:xfrm>
-            <a:off x="1508760" y="2185416"/>
-            <a:ext cx="201168" cy="201168"/>
-          </a:xfrm>
-          <a:prstGeom prst="ellipse">
-            <a:avLst/>
-          </a:prstGeom>
-          <a:solidFill>
-            <a:srgbClr val="FFE600"/>
-          </a:solidFill>
-          <a:ln>
-            <a:noFill/>
-          </a:ln>
-          <a:effectLst/>
-        </p:spPr>
-        <p:style>
-          <a:lnRef idx="1">
-            <a:schemeClr val="accent1"/>
-          </a:lnRef>
-          <a:fillRef idx="3">
-            <a:schemeClr val="accent1"/>
-          </a:fillRef>
-          <a:effectRef idx="2">
-            <a:schemeClr val="accent1"/>
-          </a:effectRef>
-          <a:fontRef idx="minor">
-            <a:schemeClr val="lt1"/>
-          </a:fontRef>
-        </p:style>
-        <p:txBody>
-          <a:bodyPr rtlCol="0" anchor="ctr" wrap="square" lIns="18288" rIns="18288" tIns="18288" bIns="18288"/>
-          <a:lstStyle/>
-          <a:p>
-            <a:pPr algn="ctr"/>
-            <a:r>
-              <a:rPr sz="850" b="1" i="0" u="none">
-                <a:solidFill>
-                  <a:srgbClr val="262626"/>
-                </a:solidFill>
-                <a:latin typeface="맑은 고딕"/>
-                <a:ea typeface="맑은 고딕"/>
-                <a:cs typeface="맑은 고딕"/>
-              </a:rPr>
-              <a:t>2</a:t>
-            </a:r>
-          </a:p>
-        </p:txBody>
-      </p:sp>
-      <p:sp>
-        <p:nvSpPr>
-          <p:cNvPr id="15" name="Rectangle 14"/>
-          <p:cNvSpPr/>
-          <p:nvPr/>
-        </p:nvSpPr>
-        <p:spPr>
-          <a:xfrm>
-            <a:off x="2011680" y="2286000"/>
-            <a:ext cx="731520" cy="713232"/>
-          </a:xfrm>
-          <a:prstGeom prst="rect">
-            <a:avLst/>
-          </a:prstGeom>
-          <a:solidFill>
-            <a:srgbClr val="EDEDED"/>
-          </a:solidFill>
-          <a:ln w="9525">
-            <a:solidFill>
-              <a:srgbClr val="D9D9D9"/>
-            </a:solidFill>
-          </a:ln>
-          <a:effectLst/>
-        </p:spPr>
-        <p:style>
-          <a:lnRef idx="1">
-            <a:schemeClr val="accent1"/>
-          </a:lnRef>
-          <a:fillRef idx="3">
-            <a:schemeClr val="accent1"/>
-          </a:fillRef>
-          <a:effectRef idx="2">
-            <a:schemeClr val="accent1"/>
-          </a:effectRef>
-          <a:fontRef idx="minor">
-            <a:schemeClr val="lt1"/>
-          </a:fontRef>
-        </p:style>
-        <p:txBody>
-          <a:bodyPr rtlCol="0" anchor="ctr" wrap="square" lIns="18288" rIns="18288" tIns="18288" bIns="18288"/>
-          <a:lstStyle/>
-          <a:p>
-            <a:pPr algn="ctr"/>
-            <a:r>
-              <a:rPr sz="950" b="1" i="0" u="none">
-                <a:solidFill>
-                  <a:srgbClr val="8C8C8C"/>
-                </a:solidFill>
-                <a:latin typeface="맑은 고딕"/>
-                <a:ea typeface="맑은 고딕"/>
-                <a:cs typeface="맑은 고딕"/>
-              </a:rPr>
-              <a:t>AI 과제</a:t>
-            </a:r>
-          </a:p>
-          <a:p>
-            <a:pPr algn="ctr"/>
-            <a:r>
-              <a:rPr sz="950" b="1" i="0" u="none">
-                <a:solidFill>
-                  <a:srgbClr val="8C8C8C"/>
-                </a:solidFill>
-                <a:latin typeface="맑은 고딕"/>
-                <a:ea typeface="맑은 고딕"/>
-                <a:cs typeface="맑은 고딕"/>
-              </a:rPr>
-              <a:t>발굴</a:t>
-            </a:r>
-          </a:p>
-        </p:txBody>
-      </p:sp>
-      <p:sp>
-        <p:nvSpPr>
-          <p:cNvPr id="16" name="Oval 15"/>
-          <p:cNvSpPr/>
-          <p:nvPr/>
-        </p:nvSpPr>
-        <p:spPr>
-          <a:xfrm>
-            <a:off x="2276856" y="2185416"/>
-            <a:ext cx="201168" cy="201168"/>
-          </a:xfrm>
-          <a:prstGeom prst="ellipse">
-            <a:avLst/>
-          </a:prstGeom>
-          <a:solidFill>
-            <a:srgbClr val="BFBFBF"/>
-          </a:solidFill>
-          <a:ln>
-            <a:noFill/>
-          </a:ln>
-          <a:effectLst/>
-        </p:spPr>
-        <p:style>
-          <a:lnRef idx="1">
-            <a:schemeClr val="accent1"/>
-          </a:lnRef>
-          <a:fillRef idx="3">
-            <a:schemeClr val="accent1"/>
-          </a:fillRef>
-          <a:effectRef idx="2">
-            <a:schemeClr val="accent1"/>
-          </a:effectRef>
-          <a:fontRef idx="minor">
-            <a:schemeClr val="lt1"/>
-          </a:fontRef>
-        </p:style>
-        <p:txBody>
-          <a:bodyPr rtlCol="0" anchor="ctr" wrap="square" lIns="18288" rIns="18288" tIns="18288" bIns="18288"/>
-          <a:lstStyle/>
-          <a:p>
-            <a:pPr algn="ctr"/>
-            <a:r>
-              <a:rPr sz="850" b="1" i="0" u="none">
-                <a:solidFill>
-                  <a:srgbClr val="262626"/>
-                </a:solidFill>
-                <a:latin typeface="맑은 고딕"/>
-                <a:ea typeface="맑은 고딕"/>
-                <a:cs typeface="맑은 고딕"/>
-              </a:rPr>
-              <a:t>3</a:t>
-            </a:r>
-          </a:p>
-        </p:txBody>
-      </p:sp>
-      <p:sp>
-        <p:nvSpPr>
-          <p:cNvPr id="17" name="Rectangle 16"/>
-          <p:cNvSpPr/>
-          <p:nvPr/>
-        </p:nvSpPr>
-        <p:spPr>
-          <a:xfrm>
-            <a:off x="2779776" y="2286000"/>
-            <a:ext cx="731520" cy="713232"/>
-          </a:xfrm>
-          <a:prstGeom prst="rect">
-            <a:avLst/>
-          </a:prstGeom>
-          <a:solidFill>
-            <a:srgbClr val="EDEDED"/>
-          </a:solidFill>
-          <a:ln w="9525">
-            <a:solidFill>
-              <a:srgbClr val="D9D9D9"/>
-            </a:solidFill>
-          </a:ln>
-          <a:effectLst/>
-        </p:spPr>
-        <p:style>
-          <a:lnRef idx="1">
-            <a:schemeClr val="accent1"/>
-          </a:lnRef>
-          <a:fillRef idx="3">
-            <a:schemeClr val="accent1"/>
-          </a:fillRef>
-          <a:effectRef idx="2">
-            <a:schemeClr val="accent1"/>
-          </a:effectRef>
-          <a:fontRef idx="minor">
-            <a:schemeClr val="lt1"/>
-          </a:fontRef>
-        </p:style>
-        <p:txBody>
-          <a:bodyPr rtlCol="0" anchor="ctr" wrap="square" lIns="18288" rIns="18288" tIns="18288" bIns="18288"/>
-          <a:lstStyle/>
-          <a:p>
-            <a:pPr algn="ctr"/>
-            <a:r>
-              <a:rPr sz="950" b="1" i="0" u="none">
-                <a:solidFill>
-                  <a:srgbClr val="8C8C8C"/>
-                </a:solidFill>
-                <a:latin typeface="맑은 고딕"/>
-                <a:ea typeface="맑은 고딕"/>
-                <a:cs typeface="맑은 고딕"/>
-              </a:rPr>
-              <a:t>과제</a:t>
-            </a:r>
-          </a:p>
-          <a:p>
-            <a:pPr algn="ctr"/>
-            <a:r>
-              <a:rPr sz="950" b="1" i="0" u="none">
-                <a:solidFill>
-                  <a:srgbClr val="8C8C8C"/>
-                </a:solidFill>
-                <a:latin typeface="맑은 고딕"/>
-                <a:ea typeface="맑은 고딕"/>
-                <a:cs typeface="맑은 고딕"/>
-              </a:rPr>
-              <a:t>우선순위화</a:t>
-            </a:r>
-          </a:p>
-        </p:txBody>
-      </p:sp>
-      <p:sp>
-        <p:nvSpPr>
-          <p:cNvPr id="18" name="Oval 17"/>
-          <p:cNvSpPr/>
-          <p:nvPr/>
-        </p:nvSpPr>
-        <p:spPr>
-          <a:xfrm>
-            <a:off x="3044952" y="2185416"/>
-            <a:ext cx="201168" cy="201168"/>
-          </a:xfrm>
-          <a:prstGeom prst="ellipse">
-            <a:avLst/>
-          </a:prstGeom>
-          <a:solidFill>
-            <a:srgbClr val="BFBFBF"/>
-          </a:solidFill>
-          <a:ln>
-            <a:noFill/>
-          </a:ln>
-          <a:effectLst/>
-        </p:spPr>
-        <p:style>
-          <a:lnRef idx="1">
-            <a:schemeClr val="accent1"/>
-          </a:lnRef>
-          <a:fillRef idx="3">
-            <a:schemeClr val="accent1"/>
-          </a:fillRef>
-          <a:effectRef idx="2">
-            <a:schemeClr val="accent1"/>
-          </a:effectRef>
-          <a:fontRef idx="minor">
-            <a:schemeClr val="lt1"/>
-          </a:fontRef>
-        </p:style>
-        <p:txBody>
-          <a:bodyPr rtlCol="0" anchor="ctr" wrap="square" lIns="18288" rIns="18288" tIns="18288" bIns="18288"/>
-          <a:lstStyle/>
-          <a:p>
-            <a:pPr algn="ctr"/>
-            <a:r>
-              <a:rPr sz="850" b="1" i="0" u="none">
-                <a:solidFill>
-                  <a:srgbClr val="262626"/>
-                </a:solidFill>
-                <a:latin typeface="맑은 고딕"/>
-                <a:ea typeface="맑은 고딕"/>
-                <a:cs typeface="맑은 고딕"/>
-              </a:rPr>
-              <a:t>4</a:t>
-            </a:r>
-          </a:p>
-        </p:txBody>
-      </p:sp>
-      <p:sp>
-        <p:nvSpPr>
-          <p:cNvPr id="19" name="Rectangle 18"/>
-          <p:cNvSpPr/>
-          <p:nvPr/>
-        </p:nvSpPr>
-        <p:spPr>
-          <a:xfrm>
-            <a:off x="3547872" y="2286000"/>
-            <a:ext cx="731520" cy="713232"/>
-          </a:xfrm>
-          <a:prstGeom prst="rect">
-            <a:avLst/>
-          </a:prstGeom>
-          <a:solidFill>
-            <a:srgbClr val="EDEDED"/>
-          </a:solidFill>
-          <a:ln w="9525">
-            <a:solidFill>
-              <a:srgbClr val="D9D9D9"/>
-            </a:solidFill>
-          </a:ln>
-          <a:effectLst/>
-        </p:spPr>
-        <p:style>
-          <a:lnRef idx="1">
-            <a:schemeClr val="accent1"/>
-          </a:lnRef>
-          <a:fillRef idx="3">
-            <a:schemeClr val="accent1"/>
-          </a:fillRef>
-          <a:effectRef idx="2">
-            <a:schemeClr val="accent1"/>
-          </a:effectRef>
-          <a:fontRef idx="minor">
-            <a:schemeClr val="lt1"/>
-          </a:fontRef>
-        </p:style>
-        <p:txBody>
-          <a:bodyPr rtlCol="0" anchor="ctr" wrap="square" lIns="18288" rIns="18288" tIns="18288" bIns="18288"/>
-          <a:lstStyle/>
-          <a:p>
-            <a:pPr algn="ctr"/>
-            <a:r>
-              <a:rPr sz="950" b="1" i="0" u="none">
-                <a:solidFill>
-                  <a:srgbClr val="8C8C8C"/>
-                </a:solidFill>
-                <a:latin typeface="맑은 고딕"/>
-                <a:ea typeface="맑은 고딕"/>
-                <a:cs typeface="맑은 고딕"/>
-              </a:rPr>
-              <a:t>To-Be</a:t>
-            </a:r>
-          </a:p>
-          <a:p>
-            <a:pPr algn="ctr"/>
-            <a:r>
-              <a:rPr sz="950" b="1" i="0" u="none">
-                <a:solidFill>
-                  <a:srgbClr val="8C8C8C"/>
-                </a:solidFill>
-                <a:latin typeface="맑은 고딕"/>
-                <a:ea typeface="맑은 고딕"/>
-                <a:cs typeface="맑은 고딕"/>
-              </a:rPr>
-              <a:t>시나리오</a:t>
-            </a:r>
-          </a:p>
-        </p:txBody>
-      </p:sp>
-      <p:sp>
-        <p:nvSpPr>
-          <p:cNvPr id="20" name="Oval 19"/>
-          <p:cNvSpPr/>
-          <p:nvPr/>
-        </p:nvSpPr>
-        <p:spPr>
-          <a:xfrm>
-            <a:off x="3813048" y="2185416"/>
-            <a:ext cx="201168" cy="201168"/>
-          </a:xfrm>
-          <a:prstGeom prst="ellipse">
-            <a:avLst/>
-          </a:prstGeom>
-          <a:solidFill>
-            <a:srgbClr val="BFBFBF"/>
-          </a:solidFill>
-          <a:ln>
-            <a:noFill/>
-          </a:ln>
-          <a:effectLst/>
-        </p:spPr>
-        <p:style>
-          <a:lnRef idx="1">
-            <a:schemeClr val="accent1"/>
-          </a:lnRef>
-          <a:fillRef idx="3">
-            <a:schemeClr val="accent1"/>
-          </a:fillRef>
-          <a:effectRef idx="2">
-            <a:schemeClr val="accent1"/>
-          </a:effectRef>
-          <a:fontRef idx="minor">
-            <a:schemeClr val="lt1"/>
-          </a:fontRef>
-        </p:style>
-        <p:txBody>
-          <a:bodyPr rtlCol="0" anchor="ctr" wrap="square" lIns="18288" rIns="18288" tIns="18288" bIns="18288"/>
-          <a:lstStyle/>
-          <a:p>
-            <a:pPr algn="ctr"/>
-            <a:r>
-              <a:rPr sz="850" b="1" i="0" u="none">
-                <a:solidFill>
-                  <a:srgbClr val="262626"/>
-                </a:solidFill>
-                <a:latin typeface="맑은 고딕"/>
-                <a:ea typeface="맑은 고딕"/>
-                <a:cs typeface="맑은 고딕"/>
-              </a:rPr>
-              <a:t>5</a:t>
-            </a:r>
-          </a:p>
-        </p:txBody>
-      </p:sp>
-      <p:sp>
-        <p:nvSpPr>
-          <p:cNvPr id="21" name="Rectangle 20"/>
-          <p:cNvSpPr/>
-          <p:nvPr/>
-        </p:nvSpPr>
-        <p:spPr>
-          <a:xfrm>
-            <a:off x="4315968" y="2286000"/>
-            <a:ext cx="731520" cy="713232"/>
-          </a:xfrm>
-          <a:prstGeom prst="rect">
-            <a:avLst/>
-          </a:prstGeom>
-          <a:solidFill>
-            <a:srgbClr val="EDEDED"/>
-          </a:solidFill>
-          <a:ln w="9525">
-            <a:solidFill>
-              <a:srgbClr val="D9D9D9"/>
-            </a:solidFill>
-          </a:ln>
-          <a:effectLst/>
-        </p:spPr>
-        <p:style>
-          <a:lnRef idx="1">
-            <a:schemeClr val="accent1"/>
-          </a:lnRef>
-          <a:fillRef idx="3">
-            <a:schemeClr val="accent1"/>
-          </a:fillRef>
-          <a:effectRef idx="2">
-            <a:schemeClr val="accent1"/>
-          </a:effectRef>
-          <a:fontRef idx="minor">
-            <a:schemeClr val="lt1"/>
-          </a:fontRef>
-        </p:style>
-        <p:txBody>
-          <a:bodyPr rtlCol="0" anchor="ctr" wrap="square" lIns="18288" rIns="18288" tIns="18288" bIns="18288"/>
-          <a:lstStyle/>
-          <a:p>
-            <a:pPr algn="ctr"/>
-            <a:r>
-              <a:rPr sz="950" b="1" i="0" u="none">
-                <a:solidFill>
-                  <a:srgbClr val="8C8C8C"/>
-                </a:solidFill>
-                <a:latin typeface="맑은 고딕"/>
-                <a:ea typeface="맑은 고딕"/>
-                <a:cs typeface="맑은 고딕"/>
-              </a:rPr>
-              <a:t>프로토타입</a:t>
-            </a:r>
-          </a:p>
-          <a:p>
-            <a:pPr algn="ctr"/>
-            <a:r>
-              <a:rPr sz="950" b="1" i="0" u="none">
-                <a:solidFill>
-                  <a:srgbClr val="8C8C8C"/>
-                </a:solidFill>
-                <a:latin typeface="맑은 고딕"/>
-                <a:ea typeface="맑은 고딕"/>
-                <a:cs typeface="맑은 고딕"/>
-              </a:rPr>
-              <a:t>구현</a:t>
-            </a:r>
-          </a:p>
-        </p:txBody>
-      </p:sp>
-      <p:sp>
-        <p:nvSpPr>
-          <p:cNvPr id="22" name="Oval 21"/>
-          <p:cNvSpPr/>
-          <p:nvPr/>
-        </p:nvSpPr>
-        <p:spPr>
-          <a:xfrm>
-            <a:off x="4581144" y="2185416"/>
-            <a:ext cx="201168" cy="201168"/>
-          </a:xfrm>
-          <a:prstGeom prst="ellipse">
-            <a:avLst/>
-          </a:prstGeom>
-          <a:solidFill>
-            <a:srgbClr val="BFBFBF"/>
-          </a:solidFill>
-          <a:ln>
-            <a:noFill/>
-          </a:ln>
-          <a:effectLst/>
-        </p:spPr>
-        <p:style>
-          <a:lnRef idx="1">
-            <a:schemeClr val="accent1"/>
-          </a:lnRef>
-          <a:fillRef idx="3">
-            <a:schemeClr val="accent1"/>
-          </a:fillRef>
-          <a:effectRef idx="2">
-            <a:schemeClr val="accent1"/>
-          </a:effectRef>
-          <a:fontRef idx="minor">
-            <a:schemeClr val="lt1"/>
-          </a:fontRef>
-        </p:style>
-        <p:txBody>
-          <a:bodyPr rtlCol="0" anchor="ctr" wrap="square" lIns="18288" rIns="18288" tIns="18288" bIns="18288"/>
-          <a:lstStyle/>
-          <a:p>
-            <a:pPr algn="ctr"/>
-            <a:r>
-              <a:rPr sz="850" b="1" i="0" u="none">
-                <a:solidFill>
-                  <a:srgbClr val="262626"/>
-                </a:solidFill>
-                <a:latin typeface="맑은 고딕"/>
-                <a:ea typeface="맑은 고딕"/>
-                <a:cs typeface="맑은 고딕"/>
-              </a:rPr>
-              <a:t>6</a:t>
-            </a:r>
-          </a:p>
-        </p:txBody>
-      </p:sp>
-      <p:sp>
-        <p:nvSpPr>
-          <p:cNvPr id="23" name="Rectangle 22"/>
-          <p:cNvSpPr/>
-          <p:nvPr/>
-        </p:nvSpPr>
-        <p:spPr>
-          <a:xfrm>
-            <a:off x="5084064" y="2286000"/>
-            <a:ext cx="731520" cy="713232"/>
-          </a:xfrm>
-          <a:prstGeom prst="rect">
-            <a:avLst/>
-          </a:prstGeom>
-          <a:solidFill>
-            <a:srgbClr val="EDEDED"/>
-          </a:solidFill>
-          <a:ln w="9525">
-            <a:solidFill>
-              <a:srgbClr val="D9D9D9"/>
-            </a:solidFill>
-          </a:ln>
-          <a:effectLst/>
-        </p:spPr>
-        <p:style>
-          <a:lnRef idx="1">
-            <a:schemeClr val="accent1"/>
-          </a:lnRef>
-          <a:fillRef idx="3">
-            <a:schemeClr val="accent1"/>
-          </a:fillRef>
-          <a:effectRef idx="2">
-            <a:schemeClr val="accent1"/>
-          </a:effectRef>
-          <a:fontRef idx="minor">
-            <a:schemeClr val="lt1"/>
-          </a:fontRef>
-        </p:style>
-        <p:txBody>
-          <a:bodyPr rtlCol="0" anchor="ctr" wrap="square" lIns="18288" rIns="18288" tIns="18288" bIns="18288"/>
-          <a:lstStyle/>
-          <a:p>
-            <a:pPr algn="ctr"/>
-            <a:r>
-              <a:rPr sz="950" b="1" i="0" u="none">
-                <a:solidFill>
-                  <a:srgbClr val="8C8C8C"/>
-                </a:solidFill>
-                <a:latin typeface="맑은 고딕"/>
-                <a:ea typeface="맑은 고딕"/>
-                <a:cs typeface="맑은 고딕"/>
-              </a:rPr>
-              <a:t>실행</a:t>
-            </a:r>
-          </a:p>
-          <a:p>
-            <a:pPr algn="ctr"/>
-            <a:r>
-              <a:rPr sz="950" b="1" i="0" u="none">
-                <a:solidFill>
-                  <a:srgbClr val="8C8C8C"/>
-                </a:solidFill>
-                <a:latin typeface="맑은 고딕"/>
-                <a:ea typeface="맑은 고딕"/>
-                <a:cs typeface="맑은 고딕"/>
-              </a:rPr>
-              <a:t>로드맵</a:t>
-            </a:r>
-          </a:p>
-        </p:txBody>
-      </p:sp>
-      <p:sp>
-        <p:nvSpPr>
-          <p:cNvPr id="24" name="Oval 23"/>
-          <p:cNvSpPr/>
-          <p:nvPr/>
-        </p:nvSpPr>
-        <p:spPr>
-          <a:xfrm>
-            <a:off x="5349240" y="2185416"/>
-            <a:ext cx="201168" cy="201168"/>
-          </a:xfrm>
-          <a:prstGeom prst="ellipse">
-            <a:avLst/>
-          </a:prstGeom>
-          <a:solidFill>
-            <a:srgbClr val="BFBFBF"/>
-          </a:solidFill>
-          <a:ln>
-            <a:noFill/>
-          </a:ln>
-          <a:effectLst/>
-        </p:spPr>
-        <p:style>
-          <a:lnRef idx="1">
-            <a:schemeClr val="accent1"/>
-          </a:lnRef>
-          <a:fillRef idx="3">
-            <a:schemeClr val="accent1"/>
-          </a:fillRef>
-          <a:effectRef idx="2">
-            <a:schemeClr val="accent1"/>
-          </a:effectRef>
-          <a:fontRef idx="minor">
-            <a:schemeClr val="lt1"/>
-          </a:fontRef>
-        </p:style>
-        <p:txBody>
-          <a:bodyPr rtlCol="0" anchor="ctr" wrap="square" lIns="18288" rIns="18288" tIns="18288" bIns="18288"/>
-          <a:lstStyle/>
-          <a:p>
-            <a:pPr algn="ctr"/>
-            <a:r>
-              <a:rPr sz="850" b="1" i="0" u="none">
-                <a:solidFill>
-                  <a:srgbClr val="262626"/>
-                </a:solidFill>
-                <a:latin typeface="맑은 고딕"/>
-                <a:ea typeface="맑은 고딕"/>
-                <a:cs typeface="맑은 고딕"/>
-              </a:rPr>
-              <a:t>7</a:t>
-            </a:r>
-          </a:p>
-        </p:txBody>
-      </p:sp>
-      <p:sp>
-        <p:nvSpPr>
-          <p:cNvPr id="25" name="TextBox 24"/>
-          <p:cNvSpPr txBox="1"/>
-          <p:nvPr/>
-        </p:nvSpPr>
-        <p:spPr>
-          <a:xfrm>
-            <a:off x="1060704" y="3017520"/>
-            <a:ext cx="1097280" cy="201168"/>
-          </a:xfrm>
-          <a:prstGeom prst="rect">
-            <a:avLst/>
-          </a:prstGeom>
-          <a:noFill/>
-        </p:spPr>
-        <p:txBody>
-          <a:bodyPr wrap="square" lIns="18288" rIns="18288" tIns="18288" bIns="18288" anchor="ctr">
-            <a:spAutoFit/>
-          </a:bodyPr>
-          <a:lstStyle/>
-          <a:p>
-            <a:pPr algn="ctr"/>
-            <a:r>
-              <a:rPr sz="900" b="1" i="0" u="none">
-                <a:solidFill>
-                  <a:srgbClr val="C62828"/>
-                </a:solidFill>
-                <a:latin typeface="맑은 고딕"/>
-                <a:ea typeface="맑은 고딕"/>
-                <a:cs typeface="맑은 고딕"/>
-              </a:rPr>
-              <a:t>▲ 현재 Task</a:t>
-            </a:r>
-          </a:p>
-        </p:txBody>
-      </p:sp>
-      <p:graphicFrame>
-        <p:nvGraphicFramePr>
-          <p:cNvPr id="26" name="Table 25"/>
-          <p:cNvGraphicFramePr>
-            <a:graphicFrameLocks noGrp="1"/>
-          </p:cNvGraphicFramePr>
-          <p:nvPr/>
-        </p:nvGraphicFramePr>
-        <p:xfrm>
-          <a:off x="365760" y="3401568"/>
-          <a:ext cx="5623560" cy="3127248"/>
-        </p:xfrm>
-        <a:graphic>
-          <a:graphicData uri="http://schemas.openxmlformats.org/drawingml/2006/table">
-            <a:tbl>
-              <a:tblPr firstRow="0" bandRow="0">
-                <a:tableStyleId>{5C22544A-7EE6-4342-B048-85BDC9FD1C3A}</a:tableStyleId>
-              </a:tblPr>
-              <a:tblGrid>
-                <a:gridCol w="1417320"/>
-                <a:gridCol w="4206240"/>
-              </a:tblGrid>
-              <a:tr h="384048">
-                <a:tc>
-                  <a:txBody>
-                    <a:bodyPr wrap="square"/>
-                    <a:lstStyle/>
-                    <a:p>
-                      <a:pPr algn="ctr">
-                        <a:spcAft>
-                          <a:spcPts val="300"/>
-                        </a:spcAft>
-                      </a:pPr>
-                      <a:r>
-                        <a:rPr sz="1300" b="1" i="0" u="none">
-                          <a:solidFill>
-                            <a:srgbClr val="FFFFFF"/>
-                          </a:solidFill>
-                          <a:latin typeface="맑은 고딕"/>
-                          <a:ea typeface="맑은 고딕"/>
-                          <a:cs typeface="맑은 고딕"/>
-                        </a:rPr>
-                        <a:t>Activity</a:t>
-                      </a:r>
-                    </a:p>
-                  </a:txBody>
-                  <a:tcPr anchor="ctr" marL="109728" marR="73152">
-                    <a:solidFill>
-                      <a:srgbClr val="404040"/>
-                    </a:solidFill>
-                  </a:tcPr>
-                </a:tc>
-                <a:tc>
-                  <a:txBody>
-                    <a:bodyPr wrap="square"/>
-                    <a:lstStyle/>
-                    <a:p>
-                      <a:pPr algn="ctr">
-                        <a:spcAft>
-                          <a:spcPts val="300"/>
-                        </a:spcAft>
-                      </a:pPr>
-                      <a:r>
-                        <a:rPr sz="1300" b="1" i="0" u="none">
-                          <a:solidFill>
-                            <a:srgbClr val="FFFFFF"/>
-                          </a:solidFill>
-                          <a:latin typeface="맑은 고딕"/>
-                          <a:ea typeface="맑은 고딕"/>
-                          <a:cs typeface="맑은 고딕"/>
-                        </a:rPr>
-                        <a:t>Activity 수행 내용 및 고려사항</a:t>
-                      </a:r>
-                    </a:p>
-                  </a:txBody>
-                  <a:tcPr anchor="ctr" marL="109728" marR="73152">
-                    <a:solidFill>
-                      <a:srgbClr val="404040"/>
-                    </a:solidFill>
-                  </a:tcPr>
-                </a:tc>
-              </a:tr>
-              <a:tr h="914400">
+              <a:tr h="685800">
                 <a:tc>
                   <a:txBody>
                     <a:bodyPr wrap="square"/>
@@ -6707,7 +4748,7 @@
                           <a:ea typeface="맑은 고딕"/>
                           <a:cs typeface="맑은 고딕"/>
                         </a:rPr>
-                        <a:t>정의·자료 분석</a:t>
+                        <a:t>분석·인터뷰</a:t>
                       </a:r>
                     </a:p>
                   </a:txBody>
@@ -6747,7 +4788,7 @@
                           <a:ea typeface="맑은 고딕"/>
                           <a:cs typeface="맑은 고딕"/>
                         </a:rPr>
-                        <a:t>상품기획~경영지원 7대 Value Chain 정의</a:t>
+                        <a:t>7대 Value Chain 정의 및 내부 전략자료·프로세스·KPI 분석</a:t>
                       </a:r>
                     </a:p>
                     <a:p>
@@ -6776,7 +4817,7 @@
                           <a:ea typeface="맑은 고딕"/>
                           <a:cs typeface="맑은 고딕"/>
                         </a:rPr>
-                        <a:t>내부 전략자료·업무 프로세스·KPI 분석</a:t>
+                        <a:t>경영진(AI 기대사항·우선순위)·실무자(업무 흐름·Pain Point) 인터뷰</a:t>
                       </a:r>
                     </a:p>
                   </a:txBody>
@@ -6787,125 +4828,7 @@
                   </a:tcPr>
                 </a:tc>
               </a:tr>
-              <a:tr h="914400">
-                <a:tc>
-                  <a:txBody>
-                    <a:bodyPr wrap="square"/>
-                    <a:lstStyle/>
-                    <a:p>
-                      <a:pPr algn="ctr">
-                        <a:spcAft>
-                          <a:spcPts val="300"/>
-                        </a:spcAft>
-                      </a:pPr>
-                      <a:r>
-                        <a:rPr sz="1200" b="1" i="0" u="none">
-                          <a:solidFill>
-                            <a:srgbClr val="262626"/>
-                          </a:solidFill>
-                          <a:latin typeface="맑은 고딕"/>
-                          <a:ea typeface="맑은 고딕"/>
-                          <a:cs typeface="맑은 고딕"/>
-                        </a:rPr>
-                        <a:t>경영진·실무자</a:t>
-                      </a:r>
-                    </a:p>
-                    <a:p>
-                      <a:pPr algn="ctr">
-                        <a:spcAft>
-                          <a:spcPts val="300"/>
-                        </a:spcAft>
-                      </a:pPr>
-                      <a:r>
-                        <a:rPr sz="1200" b="1" i="0" u="none">
-                          <a:solidFill>
-                            <a:srgbClr val="262626"/>
-                          </a:solidFill>
-                          <a:latin typeface="맑은 고딕"/>
-                          <a:ea typeface="맑은 고딕"/>
-                          <a:cs typeface="맑은 고딕"/>
-                        </a:rPr>
-                        <a:t>인터뷰</a:t>
-                      </a:r>
-                    </a:p>
-                  </a:txBody>
-                  <a:tcPr anchor="ctr" marL="109728" marR="73152">
-                    <a:solidFill>
-                      <a:srgbClr val="F2F2F2"/>
-                    </a:solidFill>
-                  </a:tcPr>
-                </a:tc>
-                <a:tc>
-                  <a:txBody>
-                    <a:bodyPr wrap="square"/>
-                    <a:lstStyle/>
-                    <a:p>
-                      <a:pPr algn="l">
-                        <a:spcAft>
-                          <a:spcPts val="300"/>
-                        </a:spcAft>
-                      </a:pPr>
-                      <a:r>
-                        <a:rPr sz="1100" b="0" i="0" u="none">
-                          <a:solidFill>
-                            <a:srgbClr val="262626"/>
-                          </a:solidFill>
-                          <a:latin typeface="맑은 고딕"/>
-                          <a:ea typeface="맑은 고딕"/>
-                          <a:cs typeface="맑은 고딕"/>
-                        </a:rPr>
-                        <a:t>• </a:t>
-                      </a:r>
-                      <a:r>
-                        <a:rPr sz="1100" b="0" i="0" u="none">
-                          <a:solidFill>
-                            <a:srgbClr val="262626"/>
-                          </a:solidFill>
-                          <a:latin typeface="맑은 고딕"/>
-                          <a:ea typeface="맑은 고딕"/>
-                          <a:cs typeface="맑은 고딕"/>
-                        </a:rPr>
-                        <a:t>경영진: 경영 방향·AI 기대사항·우선순위 청취</a:t>
-                      </a:r>
-                    </a:p>
-                    <a:p>
-                      <a:pPr algn="l">
-                        <a:spcAft>
-                          <a:spcPts val="300"/>
-                        </a:spcAft>
-                      </a:pPr>
-                      <a:r>
-                        <a:rPr sz="1100" b="0" i="0" u="none">
-                          <a:solidFill>
-                            <a:srgbClr val="262626"/>
-                          </a:solidFill>
-                          <a:latin typeface="맑은 고딕"/>
-                          <a:ea typeface="맑은 고딕"/>
-                          <a:cs typeface="맑은 고딕"/>
-                        </a:rPr>
-                        <a:t>• </a:t>
-                      </a:r>
-                      <a:r>
-                        <a:rPr sz="1100" b="0" i="0" u="none">
-                          <a:solidFill>
-                            <a:srgbClr val="262626"/>
-                          </a:solidFill>
-                          <a:latin typeface="맑은 고딕"/>
-                          <a:ea typeface="맑은 고딕"/>
-                          <a:cs typeface="맑은 고딕"/>
-                        </a:rPr>
-                        <a:t>실무자: 업무 흐름·반복 업무·Pain Point 파악</a:t>
-                      </a:r>
-                    </a:p>
-                  </a:txBody>
-                  <a:tcPr anchor="ctr" marL="109728" marR="73152">
-                    <a:solidFill>
-                      <a:srgbClr val="FFFFFF"/>
-                    </a:solidFill>
-                  </a:tcPr>
-                </a:tc>
-              </a:tr>
-              <a:tr h="914400">
+              <a:tr h="685800">
                 <a:tc>
                   <a:txBody>
                     <a:bodyPr wrap="square"/>
@@ -7147,7 +5070,7 @@
       </p:sp>
       <p:pic>
         <p:nvPicPr>
-          <p:cNvPr id="30" name="Picture 29" descr="mk_t2a.png"/>
+          <p:cNvPr id="30" name="Picture 29" descr="mk_t1b.png"/>
           <p:cNvPicPr>
             <a:picLocks noChangeAspect="1"/>
           </p:cNvPicPr>
@@ -7256,7 +5179,7 @@
                 <a:ea typeface="맑은 고딕"/>
                 <a:cs typeface="맑은 고딕"/>
               </a:rPr>
-              <a:t>Value Chain 및 핵심 업무 영역 정의서</a:t>
+              <a:t>AI 트렌드·벤치마킹 및 AI 활용 수준 진단서</a:t>
             </a:r>
           </a:p>
         </p:txBody>
@@ -7309,7 +5232,7 @@
       </p:sp>
       <p:pic>
         <p:nvPicPr>
-          <p:cNvPr id="34" name="Picture 33" descr="mk_t2b.png"/>
+          <p:cNvPr id="34" name="Picture 33" descr="mk_t2a.png"/>
           <p:cNvPicPr>
             <a:picLocks noChangeAspect="1"/>
           </p:cNvPicPr>
@@ -7418,7 +5341,7 @@
                 <a:ea typeface="맑은 고딕"/>
                 <a:cs typeface="맑은 고딕"/>
               </a:rPr>
-              <a:t>인터뷰 결과 및 Pain Point 분석서</a:t>
+              <a:t>Value Chain 분석 및 핵심 업무 영역 정의서</a:t>
             </a:r>
           </a:p>
         </p:txBody>

</xml_diff>